<commit_message>
Tekstcorrecties slide 3 en 4
Slide 4: "in beweging van" wordt "in beweging door".

Slide 3: "kiest niemand standaard zestig pagina's" was te absoluut, want
sommige organisaties schrijven wel degelijk lange stukken. Het gaat om de
keuze, niet om de lengte. Onderschrift is bovendien compacter.

Co-Authored-By: Claude Opus 5 <noreply@anthropic.com>
</commit_message>
<xml_diff>
--- a/Goed-advies-moet-ook-goed-landen.pptx
+++ b/Goed-advies-moet-ook-goed-landen.pptx
@@ -648,7 +648,7 @@
           <a:lstStyle/>
           <a:p>
             <a:r>
-              <a:t>En toch krijgen wij bijna altijd hetzelfde terug: een verslag van enkele tientallen pagina's. Dat is niet gek, dat is wat wij vier jaar lang hebben geoefend en beloond. Maar hier zit het probleem. Als er maar een vorm denkbaar is, dan is die vorm geen keuze maar een reflex. En een reflex kun je niet beoordelen op doelbewustheid. Buiten de opleiding kiest niemand standaard zestig pagina's: daar past men het vehikel aan bij doel en doelgroep. Al deze vormen zien wij nooit langskomen.  [Richttijd 3:15]</a:t>
+              <a:t>En toch krijgen wij bijna altijd hetzelfde terug: een verslag van enkele tientallen pagina's. Dat is niet gek, dat is wat wij vier jaar lang hebben geoefend en beloond. Maar hier zit het probleem. Als er maar een vorm denkbaar is, dan is die vorm geen keuze maar een reflex. En een reflex kun je niet beoordelen op doelbewustheid. Buiten de opleiding is de vorm een keuze. Soms is dat wel degelijk een lang stuk, denk aan overheidsorganisaties, maar dan is het gekozen. Van studenten krijgen wij alleen dat lange rapport.  [Richttijd 3:15]</a:t>
             </a:r>
           </a:p>
         </p:txBody>
@@ -718,7 +718,7 @@
           <a:lstStyle/>
           <a:p>
             <a:r>
-              <a:t>Dit is waar het ons om gaat. Wij leiden geen rapportenschrijvers op. Wij leiden bedrijfskundigen op die iets in beweging zetten in een organisatie. En er komt niets in beweging van een rapport dat niemand leest. Dat is waarom wij dit op tafel leggen.  [Richttijd 3:45]</a:t>
+              <a:t>Dit is waar het ons om gaat. Wij leiden geen rapportenschrijvers op. Wij leiden bedrijfskundigen op die iets in beweging zetten in een organisatie. En er komt niets in beweging door een rapport dat niemand leest. Dat is waarom wij dit op tafel leggen.  [Richttijd 3:45]</a:t>
             </a:r>
           </a:p>
         </p:txBody>
@@ -6728,7 +6728,7 @@
                 </a:solidFill>
                 <a:latin typeface="Arial"/>
               </a:rPr>
-              <a:t>Buiten de opleiding kiest niemand standaard zestig pagina's. Deze vormen zien wij nooit langskomen.</a:t>
+              <a:t>Buiten de opleiding is de vorm een keuze, soms ook een lang rapport. Van studenten krijgen wij alleen dat laatste.</a:t>
             </a:r>
           </a:p>
         </p:txBody>
@@ -7240,7 +7240,7 @@
                 </a:solidFill>
                 <a:latin typeface="Arial"/>
               </a:rPr>
-              <a:t>Er komt niets in beweging van een rapport dat niemand leest.</a:t>
+              <a:t>Er komt niets in beweging door een rapport dat niemand leest.</a:t>
             </a:r>
           </a:p>
         </p:txBody>

</xml_diff>

<commit_message>
Onderschrift slide 3 herschreven
Van een constatering over wat studenten niet doen naar een constatering over
wat professionele organisaties wel doen. Positiever geformuleerd en zonder
aanvechtbare absolute claim.

Co-Authored-By: Claude Opus 5 <noreply@anthropic.com>
</commit_message>
<xml_diff>
--- a/Goed-advies-moet-ook-goed-landen.pptx
+++ b/Goed-advies-moet-ook-goed-landen.pptx
@@ -648,7 +648,7 @@
           <a:lstStyle/>
           <a:p>
             <a:r>
-              <a:t>En toch krijgen wij bijna altijd hetzelfde terug: een verslag van enkele tientallen pagina's. Dat is niet gek, dat is wat wij vier jaar lang hebben geoefend en beloond. Maar hier zit het probleem. Als er maar een vorm denkbaar is, dan is die vorm geen keuze maar een reflex. En een reflex kun je niet beoordelen op doelbewustheid. Buiten de opleiding is de vorm een keuze. Soms is dat wel degelijk een lang stuk, denk aan overheidsorganisaties, maar dan is het gekozen. Van studenten krijgen wij alleen dat lange rapport.  [Richttijd 3:15]</a:t>
+              <a:t>En toch krijgen wij bijna altijd hetzelfde terug: een verslag van enkele tientallen pagina's. Dat is niet gek, dat is wat wij vier jaar lang hebben geoefend en beloond. Maar hier zit het probleem. Als er maar een vorm denkbaar is, dan is die vorm geen keuze maar een reflex. En een reflex kun je niet beoordelen op doelbewustheid. Professionele organisaties hanteren meerdere uitingsvormen, afhankelijk van doel en doelgroep. Soms is dat wel degelijk een lang stuk, denk aan overheidsorganisaties, maar dan is het gekozen. Van studenten krijgen wij alleen dat lange rapport.  [Richttijd 3:15]</a:t>
             </a:r>
           </a:p>
         </p:txBody>
@@ -6728,7 +6728,7 @@
                 </a:solidFill>
                 <a:latin typeface="Arial"/>
               </a:rPr>
-              <a:t>Buiten de opleiding is de vorm een keuze, soms ook een lang rapport. Van studenten krijgen wij alleen dat laatste.</a:t>
+              <a:t>Professionele organisaties hanteren meerdere uitingsvormen om hun boodschap over te brengen.</a:t>
             </a:r>
           </a:p>
         </p:txBody>

</xml_diff>